<commit_message>
fix: PPTX Statistik-Korrekturen nach Faktencheck (BA 2025)
- 42% → ~40% Widerspruchsquote (BA-Statistik 2025, inkl. Teilabhilfe)
- 30 Tage → 1 Monat Widerspruchsfrist (§ 84 SGG)
- Zeitaufwand als Praxiserfahrung gekennzeichnet
- Quellenangabe auf 2025 aktualisiert
- PPTX neu generiert

Co-Authored-By: Claude Opus 4.6 <noreply@anthropic.com>
</commit_message>
<xml_diff>
--- a/BescheidRecht_Pitch_2026.pptx
+++ b/BescheidRecht_Pitch_2026.pptx
@@ -5087,7 +5087,7 @@
               </a:defRPr>
             </a:pPr>
             <a:r>
-              <a:t>42 %</a:t>
+              <a:t>~40 %</a:t>
             </a:r>
           </a:p>
         </p:txBody>
@@ -5162,11 +5162,11 @@
             </a:r>
             <a:br/>
             <a:r>
-              <a:t>sind erfolgreich — die Fehler sind da,</a:t>
+              <a:t>sind ganz oder teilweise erfolgreich — die</a:t>
             </a:r>
             <a:br/>
             <a:r>
-              <a:t>sie werden nur nicht systematisch gefunden.</a:t>
+              <a:t>Fehler sind da, nur nicht systematisch gefunden.</a:t>
             </a:r>
           </a:p>
         </p:txBody>
@@ -5316,15 +5316,15 @@
               </a:defRPr>
             </a:pPr>
             <a:r>
-              <a:t>Verbringt eine Fachkraft mit manueller</a:t>
+              <a:t>Verbringt eine Fachkraft erfahrungsgemäß</a:t>
             </a:r>
             <a:br/>
             <a:r>
-              <a:t>Recherche, Paragraph-Suche und Brief-</a:t>
+              <a:t>mit manueller Recherche, Paragraph-Suche</a:t>
             </a:r>
             <a:br/>
             <a:r>
-              <a:t>entwurf — Zeit, die für Klienten fehlt.</a:t>
+              <a:t>und Briefentwurf — Zeit, die fehlt.</a:t>
             </a:r>
           </a:p>
         </p:txBody>
@@ -5403,7 +5403,7 @@
               </a:defRPr>
             </a:pPr>
             <a:r>
-              <a:t>30 Tage</a:t>
+              <a:t>1 Monat</a:t>
             </a:r>
           </a:p>
         </p:txBody>
@@ -5437,7 +5437,7 @@
               </a:defRPr>
             </a:pPr>
             <a:r>
-              <a:t>Widerspruchsfrist</a:t>
+              <a:t>Widerspruchsfrist (§ 84 SGG)</a:t>
             </a:r>
           </a:p>
         </p:txBody>
@@ -5474,15 +5474,15 @@
               </a:defRPr>
             </a:pPr>
             <a:r>
-              <a:t>Laufen ohne KI-Fristüberwachung ungenutzt</a:t>
+              <a:t>Läuft ohne systematische Fristüberwachung</a:t>
             </a:r>
             <a:br/>
             <a:r>
-              <a:t>ab. Verpasste Frist = kein Widerspruch</a:t>
+              <a:t>ungenutzt ab. Verpasste Frist = kein</a:t>
             </a:r>
             <a:br/>
             <a:r>
-              <a:t>mehr möglich.</a:t>
+              <a:t>Widerspruch mehr möglich.</a:t>
             </a:r>
           </a:p>
         </p:txBody>
@@ -5629,7 +5629,7 @@
               </a:defRPr>
             </a:pPr>
             <a:r>
-              <a:t>* Quelle: Statistik der Bundesagentur für Arbeit, Widersprüche und Klagen SGB II (2024)</a:t>
+              <a:t>* Quelle: Statistik der Bundesagentur für Arbeit, Widersprüche und Klagen SGB II (2025). Inkl. Teilabhilfe.</a:t>
             </a:r>
           </a:p>
         </p:txBody>

</xml_diff>